<commit_message>
tighten NVC deliverables: PDF fits 3-page limit, refresh PPTX
Co-Authored-By: Claude Opus 4.6 <noreply@anthropic.com>
</commit_message>
<xml_diff>
--- a/website/nvc/Parachute.pptx
+++ b/website/nvc/Parachute.pptx
@@ -3268,11 +3268,11 @@
               </a:defRPr>
             </a:pPr>
             <a:r>
-              <a:t>Everyone is building</a:t>
+              <a:t>Everyone is racing to build</a:t>
             </a:r>
             <a:br/>
             <a:r>
-              <a:t>personal AI computers.</a:t>
+              <a:t>your AI agent.</a:t>
             </a:r>
           </a:p>
         </p:txBody>
@@ -3317,11 +3317,11 @@
               </a:defRPr>
             </a:pPr>
             <a:r>
+              <a:t>OpenClaw. Claude Cowork. ZoComputer. Perplexity Computer. Manus.</a:t>
+            </a:r>
+            <a:br/>
+            <a:r>
               <a:t>Over 100 million people already pay $20+/month for AI.</a:t>
-            </a:r>
-            <a:br/>
-            <a:r>
-              <a:t>OpenClaw. Claude Cowork. ZoComputer. Perplexity Computer. Manus.</a:t>
             </a:r>
           </a:p>
         </p:txBody>
@@ -3456,7 +3456,7 @@
               </a:defRPr>
             </a:pPr>
             <a:r>
-              <a:t>But they’re building walled gardens — and only for the 5% who are already power users.</a:t>
+              <a:t>Features get cloned in weeks. It’s a race to the bottom. So we stopped trying to win it.</a:t>
             </a:r>
           </a:p>
         </p:txBody>
@@ -3606,7 +3606,7 @@
               </a:defRPr>
             </a:pPr>
             <a:r>
-              <a:t>THE OPPORTUNITY</a:t>
+              <a:t>THE PROBLEM</a:t>
             </a:r>
           </a:p>
         </p:txBody>
@@ -3651,11 +3651,11 @@
               </a:defRPr>
             </a:pPr>
             <a:r>
-              <a:t>The other 95% just want</a:t>
+              <a:t>Memory is shallow.</a:t>
             </a:r>
             <a:br/>
             <a:r>
-              <a:t>something that works.</a:t>
+              <a:t>Capture is broken.</a:t>
             </a:r>
           </a:p>
         </p:txBody>
@@ -3670,59 +3670,6 @@
           <a:xfrm>
             <a:off x="1097280" y="3200400"/>
             <a:ext cx="9144000" cy="1371600"/>
-          </a:xfrm>
-          <a:prstGeom prst="rect">
-            <a:avLst/>
-          </a:prstGeom>
-          <a:noFill/>
-        </p:spPr>
-        <p:txBody>
-          <a:bodyPr wrap="square">
-            <a:spAutoFit/>
-          </a:bodyPr>
-          <a:lstStyle/>
-          <a:p>
-            <a:pPr algn="l">
-              <a:lnSpc>
-                <a:spcPct val="160000"/>
-              </a:lnSpc>
-              <a:spcBef>
-                <a:spcPts val="0"/>
-              </a:spcBef>
-              <a:spcAft>
-                <a:spcPts val="0"/>
-              </a:spcAft>
-              <a:defRPr sz="2200" b="0">
-                <a:solidFill>
-                  <a:srgbClr val="6B6860"/>
-                </a:solidFill>
-                <a:latin typeface="Georgia"/>
-              </a:defRPr>
-            </a:pPr>
-            <a:r>
-              <a:t>The artist who wants to organize creative ideas.</a:t>
-            </a:r>
-            <a:br/>
-            <a:r>
-              <a:t>The small business owner tracking their days.</a:t>
-            </a:r>
-            <a:br/>
-            <a:r>
-              <a:t>The parent who wants a better way to remember and reflect.</a:t>
-            </a:r>
-          </a:p>
-        </p:txBody>
-      </p:sp>
-      <p:sp>
-        <p:nvSpPr>
-          <p:cNvPr id="7" name="TextBox 6"/>
-          <p:cNvSpPr txBox="1"/>
-          <p:nvPr/>
-        </p:nvSpPr>
-        <p:spPr>
-          <a:xfrm>
-            <a:off x="1097280" y="5212080"/>
-            <a:ext cx="9144000" cy="914400"/>
           </a:xfrm>
           <a:prstGeom prst="rect">
             <a:avLst/>
@@ -3745,7 +3692,113 @@
               <a:spcAft>
                 <a:spcPts val="0"/>
               </a:spcAft>
-              <a:defRPr sz="2200" b="0">
+              <a:defRPr sz="2000" b="0">
+                <a:solidFill>
+                  <a:srgbClr val="6B6860"/>
+                </a:solidFill>
+                <a:latin typeface="Calibri"/>
+              </a:defRPr>
+            </a:pPr>
+            <a:r>
+              <a:t>These platforms all have memory now — but it’s shallow.</a:t>
+            </a:r>
+            <a:br/>
+            <a:r>
+              <a:t>Basically one big text file. It remembers your name,</a:t>
+            </a:r>
+            <a:br/>
+            <a:r>
+              <a:t>not six months of your thinking.</a:t>
+            </a:r>
+          </a:p>
+        </p:txBody>
+      </p:sp>
+      <p:sp>
+        <p:nvSpPr>
+          <p:cNvPr id="7" name="TextBox 6"/>
+          <p:cNvSpPr txBox="1"/>
+          <p:nvPr/>
+        </p:nvSpPr>
+        <p:spPr>
+          <a:xfrm>
+            <a:off x="1097280" y="4572000"/>
+            <a:ext cx="9144000" cy="1097280"/>
+          </a:xfrm>
+          <a:prstGeom prst="rect">
+            <a:avLst/>
+          </a:prstGeom>
+          <a:noFill/>
+        </p:spPr>
+        <p:txBody>
+          <a:bodyPr wrap="square">
+            <a:spAutoFit/>
+          </a:bodyPr>
+          <a:lstStyle/>
+          <a:p>
+            <a:pPr algn="l">
+              <a:lnSpc>
+                <a:spcPct val="150000"/>
+              </a:lnSpc>
+              <a:spcBef>
+                <a:spcPts val="0"/>
+              </a:spcBef>
+              <a:spcAft>
+                <a:spcPts val="0"/>
+              </a:spcAft>
+              <a:defRPr sz="1800" b="0">
+                <a:solidFill>
+                  <a:srgbClr val="6B6860"/>
+                </a:solidFill>
+                <a:latin typeface="Calibri"/>
+              </a:defRPr>
+            </a:pPr>
+            <a:r>
+              <a:t>And there’s a deeper problem: how your thinking gets into</a:t>
+            </a:r>
+            <a:br/>
+            <a:r>
+              <a:t>the system. You can talk to your AI, but that’s a conversation —</a:t>
+            </a:r>
+            <a:br/>
+            <a:r>
+              <a:t>the AI is always in the middle.</a:t>
+            </a:r>
+          </a:p>
+        </p:txBody>
+      </p:sp>
+      <p:sp>
+        <p:nvSpPr>
+          <p:cNvPr id="8" name="TextBox 7"/>
+          <p:cNvSpPr txBox="1"/>
+          <p:nvPr/>
+        </p:nvSpPr>
+        <p:spPr>
+          <a:xfrm>
+            <a:off x="1097280" y="5760720"/>
+            <a:ext cx="9144000" cy="548640"/>
+          </a:xfrm>
+          <a:prstGeom prst="rect">
+            <a:avLst/>
+          </a:prstGeom>
+          <a:noFill/>
+        </p:spPr>
+        <p:txBody>
+          <a:bodyPr wrap="square">
+            <a:spAutoFit/>
+          </a:bodyPr>
+          <a:lstStyle/>
+          <a:p>
+            <a:pPr algn="l">
+              <a:lnSpc>
+                <a:spcPct val="130000"/>
+              </a:lnSpc>
+              <a:spcBef>
+                <a:spcPts val="0"/>
+              </a:spcBef>
+              <a:spcAft>
+                <a:spcPts val="0"/>
+              </a:spcAft>
+              <a:defRPr sz="2000" b="0">
                 <a:solidFill>
                   <a:srgbClr val="2C2A26"/>
                 </a:solidFill>
@@ -3753,11 +3806,11 @@
               </a:defRPr>
             </a:pPr>
             <a:r>
-              <a:t>They need a system that learns them —</a:t>
+              <a:t>Tools that help us think for ourselves — not just think with AI —</a:t>
             </a:r>
             <a:br/>
             <a:r>
-              <a:t>not one that demands they learn it.</a:t>
+              <a:t>produce the quality of thinking that makes AI most useful.</a:t>
             </a:r>
           </a:p>
         </p:txBody>
@@ -3952,11 +4005,11 @@
               </a:defRPr>
             </a:pPr>
             <a:r>
-              <a:t>Parachute Computer.</a:t>
+              <a:t>Parachute Daily.</a:t>
             </a:r>
             <a:br/>
             <a:r>
-              <a:t>The personal AI you can trust.</a:t>
+              <a:t>Just talk.</a:t>
             </a:r>
           </a:p>
         </p:txBody>
@@ -3969,8 +4022,116 @@
         </p:nvSpPr>
         <p:spPr>
           <a:xfrm>
-            <a:off x="1188720" y="3218688"/>
-            <a:ext cx="274320" cy="320040"/>
+            <a:off x="1097280" y="3200400"/>
+            <a:ext cx="5029200" cy="2560320"/>
+          </a:xfrm>
+          <a:prstGeom prst="rect">
+            <a:avLst/>
+          </a:prstGeom>
+          <a:noFill/>
+        </p:spPr>
+        <p:txBody>
+          <a:bodyPr wrap="square">
+            <a:spAutoFit/>
+          </a:bodyPr>
+          <a:lstStyle/>
+          <a:p>
+            <a:pPr algn="l">
+              <a:lnSpc>
+                <a:spcPct val="150000"/>
+              </a:lnSpc>
+              <a:spcBef>
+                <a:spcPts val="0"/>
+              </a:spcBef>
+              <a:spcAft>
+                <a:spcPts val="0"/>
+              </a:spcAft>
+              <a:defRPr sz="1800" b="0">
+                <a:solidFill>
+                  <a:srgbClr val="6B6860"/>
+                </a:solidFill>
+                <a:latin typeface="Calibri"/>
+              </a:defRPr>
+            </a:pPr>
+            <a:r>
+              <a:t>A voice-first journal.</a:t>
+            </a:r>
+            <a:br/>
+            <a:br/>
+            <a:r>
+              <a:t>Speak into a wearable pendant or your phone —</a:t>
+            </a:r>
+            <a:br/>
+            <a:r>
+              <a:t>on a walk, in the car, wherever thinking happens.</a:t>
+            </a:r>
+            <a:br/>
+            <a:br/>
+            <a:r>
+              <a:t>Simple for humans. Native for AI.</a:t>
+            </a:r>
+            <a:br/>
+            <a:r>
+              <a:t>No learning curve. Just talk.</a:t>
+            </a:r>
+          </a:p>
+        </p:txBody>
+      </p:sp>
+      <p:sp>
+        <p:nvSpPr>
+          <p:cNvPr id="7" name="Rounded Rectangle 6"/>
+          <p:cNvSpPr/>
+          <p:nvPr/>
+        </p:nvSpPr>
+        <p:spPr>
+          <a:xfrm>
+            <a:off x="7132320" y="3200400"/>
+            <a:ext cx="4114800" cy="2743200"/>
+          </a:xfrm>
+          <a:prstGeom prst="roundRect">
+            <a:avLst/>
+          </a:prstGeom>
+          <a:solidFill>
+            <a:srgbClr val="F3F0EA"/>
+          </a:solidFill>
+          <a:ln w="12700">
+            <a:solidFill>
+              <a:srgbClr val="E4E0D8"/>
+            </a:solidFill>
+          </a:ln>
+        </p:spPr>
+        <p:style>
+          <a:lnRef idx="1">
+            <a:schemeClr val="accent1"/>
+          </a:lnRef>
+          <a:fillRef idx="3">
+            <a:schemeClr val="accent1"/>
+          </a:fillRef>
+          <a:effectRef idx="2">
+            <a:schemeClr val="accent1"/>
+          </a:effectRef>
+          <a:fontRef idx="minor">
+            <a:schemeClr val="lt1"/>
+          </a:fontRef>
+        </p:style>
+        <p:txBody>
+          <a:bodyPr rtlCol="0" anchor="ctr"/>
+          <a:lstStyle/>
+          <a:p>
+            <a:pPr algn="ctr"/>
+          </a:p>
+        </p:txBody>
+      </p:sp>
+      <p:sp>
+        <p:nvSpPr>
+          <p:cNvPr id="8" name="TextBox 7"/>
+          <p:cNvSpPr txBox="1"/>
+          <p:nvPr/>
+        </p:nvSpPr>
+        <p:spPr>
+          <a:xfrm>
+            <a:off x="7498079" y="3474720"/>
+            <a:ext cx="3383280" cy="365760"/>
           </a:xfrm>
           <a:prstGeom prst="rect">
             <a:avLst/>
@@ -3993,7 +4154,7 @@
               <a:spcAft>
                 <a:spcPts val="0"/>
               </a:spcAft>
-              <a:defRPr sz="1600" b="0">
+              <a:defRPr sz="1100" b="1">
                 <a:solidFill>
                   <a:srgbClr val="4A7C59"/>
                 </a:solidFill>
@@ -4001,21 +4162,21 @@
               </a:defRPr>
             </a:pPr>
             <a:r>
-              <a:t>•</a:t>
-            </a:r>
-          </a:p>
-        </p:txBody>
-      </p:sp>
-      <p:sp>
-        <p:nvSpPr>
-          <p:cNvPr id="7" name="TextBox 6"/>
+              <a:t>THE PENDANT</a:t>
+            </a:r>
+          </a:p>
+        </p:txBody>
+      </p:sp>
+      <p:sp>
+        <p:nvSpPr>
+          <p:cNvPr id="9" name="TextBox 8"/>
           <p:cNvSpPr txBox="1"/>
           <p:nvPr/>
         </p:nvSpPr>
         <p:spPr>
           <a:xfrm>
-            <a:off x="1554480" y="3200400"/>
-            <a:ext cx="8229600" cy="365760"/>
+            <a:off x="7498079" y="3931920"/>
+            <a:ext cx="3383280" cy="1828800"/>
           </a:xfrm>
           <a:prstGeom prst="rect">
             <a:avLst/>
@@ -4030,7 +4191,7 @@
           <a:p>
             <a:pPr algn="l">
               <a:lnSpc>
-                <a:spcPct val="130000"/>
+                <a:spcPct val="145000"/>
               </a:lnSpc>
               <a:spcBef>
                 <a:spcPts val="0"/>
@@ -4038,7 +4199,7 @@
               <a:spcAft>
                 <a:spcPts val="0"/>
               </a:spcAft>
-              <a:defRPr sz="1800" b="0">
+              <a:defRPr sz="1600" b="0">
                 <a:solidFill>
                   <a:srgbClr val="6B6860"/>
                 </a:solidFill>
@@ -4046,371 +4207,25 @@
               </a:defRPr>
             </a:pPr>
             <a:r>
-              <a:t>Open source (AGPL-3.0) · local-first · self-hostable</a:t>
-            </a:r>
-          </a:p>
-        </p:txBody>
-      </p:sp>
-      <p:sp>
-        <p:nvSpPr>
-          <p:cNvPr id="8" name="TextBox 7"/>
-          <p:cNvSpPr txBox="1"/>
-          <p:nvPr/>
-        </p:nvSpPr>
-        <p:spPr>
-          <a:xfrm>
-            <a:off x="1188720" y="3721608"/>
-            <a:ext cx="274320" cy="320040"/>
-          </a:xfrm>
-          <a:prstGeom prst="rect">
-            <a:avLst/>
-          </a:prstGeom>
-          <a:noFill/>
-        </p:spPr>
-        <p:txBody>
-          <a:bodyPr wrap="square">
-            <a:spAutoFit/>
-          </a:bodyPr>
-          <a:lstStyle/>
-          <a:p>
-            <a:pPr algn="l">
-              <a:lnSpc>
-                <a:spcPct val="120000"/>
-              </a:lnSpc>
-              <a:spcBef>
-                <a:spcPts val="0"/>
-              </a:spcBef>
-              <a:spcAft>
-                <a:spcPts val="0"/>
-              </a:spcAft>
-              <a:defRPr sz="1600" b="0">
-                <a:solidFill>
-                  <a:srgbClr val="4A7C59"/>
-                </a:solidFill>
-                <a:latin typeface="Calibri"/>
-              </a:defRPr>
-            </a:pPr>
-            <a:r>
-              <a:t>•</a:t>
-            </a:r>
-          </a:p>
-        </p:txBody>
-      </p:sp>
-      <p:sp>
-        <p:nvSpPr>
-          <p:cNvPr id="9" name="TextBox 8"/>
-          <p:cNvSpPr txBox="1"/>
-          <p:nvPr/>
-        </p:nvSpPr>
-        <p:spPr>
-          <a:xfrm>
-            <a:off x="1554480" y="3703320"/>
-            <a:ext cx="8229600" cy="365760"/>
-          </a:xfrm>
-          <a:prstGeom prst="rect">
-            <a:avLst/>
-          </a:prstGeom>
-          <a:noFill/>
-        </p:spPr>
-        <p:txBody>
-          <a:bodyPr wrap="square">
-            <a:spAutoFit/>
-          </a:bodyPr>
-          <a:lstStyle/>
-          <a:p>
-            <a:pPr algn="l">
-              <a:lnSpc>
-                <a:spcPct val="130000"/>
-              </a:lnSpc>
-              <a:spcBef>
-                <a:spcPts val="0"/>
-              </a:spcBef>
-              <a:spcAft>
-                <a:spcPts val="0"/>
-              </a:spcAft>
-              <a:defRPr sz="1800" b="0">
-                <a:solidFill>
-                  <a:srgbClr val="6B6860"/>
-                </a:solidFill>
-                <a:latin typeface="Calibri"/>
-              </a:defRPr>
-            </a:pPr>
-            <a:r>
-              <a:t>Your data stays on your device — portable and exportable</a:t>
-            </a:r>
-          </a:p>
-        </p:txBody>
-      </p:sp>
-      <p:sp>
-        <p:nvSpPr>
-          <p:cNvPr id="10" name="TextBox 9"/>
-          <p:cNvSpPr txBox="1"/>
-          <p:nvPr/>
-        </p:nvSpPr>
-        <p:spPr>
-          <a:xfrm>
-            <a:off x="1188720" y="4224528"/>
-            <a:ext cx="274320" cy="320040"/>
-          </a:xfrm>
-          <a:prstGeom prst="rect">
-            <a:avLst/>
-          </a:prstGeom>
-          <a:noFill/>
-        </p:spPr>
-        <p:txBody>
-          <a:bodyPr wrap="square">
-            <a:spAutoFit/>
-          </a:bodyPr>
-          <a:lstStyle/>
-          <a:p>
-            <a:pPr algn="l">
-              <a:lnSpc>
-                <a:spcPct val="120000"/>
-              </a:lnSpc>
-              <a:spcBef>
-                <a:spcPts val="0"/>
-              </a:spcBef>
-              <a:spcAft>
-                <a:spcPts val="0"/>
-              </a:spcAft>
-              <a:defRPr sz="1600" b="0">
-                <a:solidFill>
-                  <a:srgbClr val="4A7C59"/>
-                </a:solidFill>
-                <a:latin typeface="Calibri"/>
-              </a:defRPr>
-            </a:pPr>
-            <a:r>
-              <a:t>•</a:t>
-            </a:r>
-          </a:p>
-        </p:txBody>
-      </p:sp>
-      <p:sp>
-        <p:nvSpPr>
-          <p:cNvPr id="11" name="TextBox 10"/>
-          <p:cNvSpPr txBox="1"/>
-          <p:nvPr/>
-        </p:nvSpPr>
-        <p:spPr>
-          <a:xfrm>
-            <a:off x="1554480" y="4206240"/>
-            <a:ext cx="8229600" cy="365760"/>
-          </a:xfrm>
-          <a:prstGeom prst="rect">
-            <a:avLst/>
-          </a:prstGeom>
-          <a:noFill/>
-        </p:spPr>
-        <p:txBody>
-          <a:bodyPr wrap="square">
-            <a:spAutoFit/>
-          </a:bodyPr>
-          <a:lstStyle/>
-          <a:p>
-            <a:pPr algn="l">
-              <a:lnSpc>
-                <a:spcPct val="130000"/>
-              </a:lnSpc>
-              <a:spcBef>
-                <a:spcPts val="0"/>
-              </a:spcBef>
-              <a:spcAft>
-                <a:spcPts val="0"/>
-              </a:spcAft>
-              <a:defRPr sz="1800" b="0">
-                <a:solidFill>
-                  <a:srgbClr val="6B6860"/>
-                </a:solidFill>
-                <a:latin typeface="Calibri"/>
-              </a:defRPr>
-            </a:pPr>
-            <a:r>
-              <a:t>Knowledge graph connects your journals, conversations, and thinking</a:t>
-            </a:r>
-          </a:p>
-        </p:txBody>
-      </p:sp>
-      <p:sp>
-        <p:nvSpPr>
-          <p:cNvPr id="12" name="TextBox 11"/>
-          <p:cNvSpPr txBox="1"/>
-          <p:nvPr/>
-        </p:nvSpPr>
-        <p:spPr>
-          <a:xfrm>
-            <a:off x="1188720" y="4727448"/>
-            <a:ext cx="274320" cy="320040"/>
-          </a:xfrm>
-          <a:prstGeom prst="rect">
-            <a:avLst/>
-          </a:prstGeom>
-          <a:noFill/>
-        </p:spPr>
-        <p:txBody>
-          <a:bodyPr wrap="square">
-            <a:spAutoFit/>
-          </a:bodyPr>
-          <a:lstStyle/>
-          <a:p>
-            <a:pPr algn="l">
-              <a:lnSpc>
-                <a:spcPct val="120000"/>
-              </a:lnSpc>
-              <a:spcBef>
-                <a:spcPts val="0"/>
-              </a:spcBef>
-              <a:spcAft>
-                <a:spcPts val="0"/>
-              </a:spcAft>
-              <a:defRPr sz="1600" b="0">
-                <a:solidFill>
-                  <a:srgbClr val="4A7C59"/>
-                </a:solidFill>
-                <a:latin typeface="Calibri"/>
-              </a:defRPr>
-            </a:pPr>
-            <a:r>
-              <a:t>•</a:t>
-            </a:r>
-          </a:p>
-        </p:txBody>
-      </p:sp>
-      <p:sp>
-        <p:nvSpPr>
-          <p:cNvPr id="13" name="TextBox 12"/>
-          <p:cNvSpPr txBox="1"/>
-          <p:nvPr/>
-        </p:nvSpPr>
-        <p:spPr>
-          <a:xfrm>
-            <a:off x="1554480" y="4709160"/>
-            <a:ext cx="8229600" cy="365760"/>
-          </a:xfrm>
-          <a:prstGeom prst="rect">
-            <a:avLst/>
-          </a:prstGeom>
-          <a:noFill/>
-        </p:spPr>
-        <p:txBody>
-          <a:bodyPr wrap="square">
-            <a:spAutoFit/>
-          </a:bodyPr>
-          <a:lstStyle/>
-          <a:p>
-            <a:pPr algn="l">
-              <a:lnSpc>
-                <a:spcPct val="130000"/>
-              </a:lnSpc>
-              <a:spcBef>
-                <a:spcPts val="0"/>
-              </a:spcBef>
-              <a:spcAft>
-                <a:spcPts val="0"/>
-              </a:spcAft>
-              <a:defRPr sz="1800" b="0">
-                <a:solidFill>
-                  <a:srgbClr val="6B6860"/>
-                </a:solidFill>
-                <a:latin typeface="Calibri"/>
-              </a:defRPr>
-            </a:pPr>
-            <a:r>
-              <a:t>Public Benefit Corporation — legally mandated to serve users</a:t>
-            </a:r>
-          </a:p>
-        </p:txBody>
-      </p:sp>
-      <p:sp>
-        <p:nvSpPr>
-          <p:cNvPr id="14" name="TextBox 13"/>
-          <p:cNvSpPr txBox="1"/>
-          <p:nvPr/>
-        </p:nvSpPr>
-        <p:spPr>
-          <a:xfrm>
-            <a:off x="1097280" y="5303520"/>
-            <a:ext cx="9144000" cy="731520"/>
-          </a:xfrm>
-          <a:prstGeom prst="rect">
-            <a:avLst/>
-          </a:prstGeom>
-          <a:noFill/>
-        </p:spPr>
-        <p:txBody>
-          <a:bodyPr wrap="square">
-            <a:spAutoFit/>
-          </a:bodyPr>
-          <a:lstStyle/>
-          <a:p>
-            <a:pPr algn="l">
-              <a:lnSpc>
-                <a:spcPct val="130000"/>
-              </a:lnSpc>
-              <a:spcBef>
-                <a:spcPts val="0"/>
-              </a:spcBef>
-              <a:spcAft>
-                <a:spcPts val="0"/>
-              </a:spcAft>
-              <a:defRPr sz="2200" b="0">
-                <a:solidFill>
-                  <a:srgbClr val="2C2A26"/>
-                </a:solidFill>
-                <a:latin typeface="Georgia"/>
-              </a:defRPr>
-            </a:pPr>
-            <a:r>
-              <a:t>Software gets cloned in a day.</a:t>
+              <a:t>Wearable voice capture device.</a:t>
             </a:r>
             <a:br/>
-            <a:r>
-              <a:t>Trust and context cannot.</a:t>
-            </a:r>
-          </a:p>
-        </p:txBody>
-      </p:sp>
-      <p:sp>
-        <p:nvSpPr>
-          <p:cNvPr id="15" name="TextBox 14"/>
-          <p:cNvSpPr txBox="1"/>
-          <p:nvPr/>
-        </p:nvSpPr>
-        <p:spPr>
-          <a:xfrm>
-            <a:off x="1097280" y="6035040"/>
-            <a:ext cx="9144000" cy="457200"/>
-          </a:xfrm>
-          <a:prstGeom prst="rect">
-            <a:avLst/>
-          </a:prstGeom>
-          <a:noFill/>
-        </p:spPr>
-        <p:txBody>
-          <a:bodyPr wrap="square">
-            <a:spAutoFit/>
-          </a:bodyPr>
-          <a:lstStyle/>
-          <a:p>
-            <a:pPr algn="l">
-              <a:lnSpc>
-                <a:spcPct val="120000"/>
-              </a:lnSpc>
-              <a:spcBef>
-                <a:spcPts val="0"/>
-              </a:spcBef>
-              <a:spcAft>
-                <a:spcPts val="0"/>
-              </a:spcAft>
-              <a:defRPr sz="1800" b="0">
-                <a:solidFill>
-                  <a:srgbClr val="6B6860"/>
-                </a:solidFill>
-                <a:latin typeface="Georgia"/>
-              </a:defRPr>
-            </a:pPr>
-            <a:r>
-              <a:t>But most people don’t want to self-host a server.</a:t>
+            <a:br/>
+            <a:r>
+              <a:t>Press a button. Talk.</a:t>
+            </a:r>
+            <a:br/>
+            <a:r>
+              <a:t>Your thoughts are transcribed and</a:t>
+            </a:r>
+            <a:br/>
+            <a:r>
+              <a:t>structured by the time you’re home.</a:t>
+            </a:r>
+            <a:br/>
+            <a:br/>
+            <a:r>
+              <a:t>Working prototype on stage today.</a:t>
             </a:r>
           </a:p>
         </p:txBody>
@@ -4560,7 +4375,7 @@
               </a:defRPr>
             </a:pPr>
             <a:r>
-              <a:t>THE BRIDGE</a:t>
+              <a:t>AGENT-NATIVE</a:t>
             </a:r>
           </a:p>
         </p:txBody>
@@ -4605,11 +4420,11 @@
               </a:defRPr>
             </a:pPr>
             <a:r>
-              <a:t>Parachute Daily.</a:t>
+              <a:t>Don’t compete with agents.</a:t>
             </a:r>
             <a:br/>
             <a:r>
-              <a:t>Just talk.</a:t>
+              <a:t>Build the tool layer they all need.</a:t>
             </a:r>
           </a:p>
         </p:txBody>
@@ -4623,7 +4438,7 @@
         <p:spPr>
           <a:xfrm>
             <a:off x="1097280" y="3200400"/>
-            <a:ext cx="5029200" cy="2560320"/>
+            <a:ext cx="5029200" cy="1371600"/>
           </a:xfrm>
           <a:prstGeom prst="rect">
             <a:avLst/>
@@ -4654,33 +4469,20 @@
               </a:defRPr>
             </a:pPr>
             <a:r>
-              <a:t>A voice-first journal.</a:t>
+              <a:t>Your data lives in a graph database organized around</a:t>
+            </a:r>
+            <a:br/>
+            <a:r>
+              <a:t>three primitives: Things, Tags, and Tools.</a:t>
             </a:r>
             <a:br/>
             <a:br/>
             <a:r>
-              <a:t>Speak into a wearable pendant or your phone —</a:t>
+              <a:t>The whole system speaks MCP — the open standard</a:t>
             </a:r>
             <a:br/>
             <a:r>
-              <a:t>on a walk, in the car, wherever thinking happens.</a:t>
-            </a:r>
-            <a:br/>
-            <a:br/>
-            <a:r>
-              <a:t>AI weaves through gently:</a:t>
-            </a:r>
-            <a:br/>
-            <a:r>
-              <a:t>  ·  Daily reflections on your entries</a:t>
-            </a:r>
-            <a:br/>
-            <a:r>
-              <a:t>  ·  Pattern recognition over time</a:t>
-            </a:r>
-            <a:br/>
-            <a:r>
-              <a:t>  ·  Weekly synthesis of your thinking</a:t>
+              <a:t>for connecting AI to tools.</a:t>
             </a:r>
           </a:p>
         </p:txBody>
@@ -4693,8 +4495,8 @@
         </p:nvSpPr>
         <p:spPr>
           <a:xfrm>
-            <a:off x="1097280" y="5943600"/>
-            <a:ext cx="5029200" cy="457200"/>
+            <a:off x="1097280" y="4846320"/>
+            <a:ext cx="5029200" cy="914400"/>
           </a:xfrm>
           <a:prstGeom prst="rect">
             <a:avLst/>
@@ -4709,7 +4511,7 @@
           <a:p>
             <a:pPr algn="l">
               <a:lnSpc>
-                <a:spcPct val="120000"/>
+                <a:spcPct val="150000"/>
               </a:lnSpc>
               <a:spcBef>
                 <a:spcPts val="0"/>
@@ -4717,15 +4519,19 @@
               <a:spcAft>
                 <a:spcPts val="0"/>
               </a:spcAft>
-              <a:defRPr sz="1800" b="0">
-                <a:solidFill>
-                  <a:srgbClr val="2C2A26"/>
+              <a:defRPr sz="1600" b="0">
+                <a:solidFill>
+                  <a:srgbClr val="6B6860"/>
                 </a:solidFill>
                 <a:latin typeface="Calibri"/>
               </a:defRPr>
             </a:pPr>
             <a:r>
-              <a:t>No learning curve. No technical sophistication required.</a:t>
+              <a:t>Your AI can read, search, and create structure.</a:t>
+            </a:r>
+            <a:br/>
+            <a:r>
+              <a:t>People nodes. Project nodes. A living knowledge graph.</a:t>
             </a:r>
           </a:p>
         </p:txBody>
@@ -4738,14 +4544,14 @@
         </p:nvSpPr>
         <p:spPr>
           <a:xfrm>
-            <a:off x="7132320" y="3200400"/>
-            <a:ext cx="4114800" cy="2743200"/>
+            <a:off x="6858000" y="2743200"/>
+            <a:ext cx="4572000" cy="3657600"/>
           </a:xfrm>
           <a:prstGeom prst="roundRect">
             <a:avLst/>
           </a:prstGeom>
           <a:solidFill>
-            <a:srgbClr val="F3F0EA"/>
+            <a:srgbClr val="FFFFFF"/>
           </a:solidFill>
           <a:ln w="12700">
             <a:solidFill>
@@ -4783,8 +4589,8 @@
         </p:nvSpPr>
         <p:spPr>
           <a:xfrm>
-            <a:off x="7498079" y="3474720"/>
-            <a:ext cx="3383280" cy="365760"/>
+            <a:off x="7223760" y="2926080"/>
+            <a:ext cx="3657600" cy="274320"/>
           </a:xfrm>
           <a:prstGeom prst="rect">
             <a:avLst/>
@@ -4807,15 +4613,15 @@
               <a:spcAft>
                 <a:spcPts val="0"/>
               </a:spcAft>
-              <a:defRPr sz="1100" b="1">
-                <a:solidFill>
-                  <a:srgbClr val="4A7C59"/>
-                </a:solidFill>
-                <a:latin typeface="Calibri"/>
+              <a:defRPr sz="1000" b="1">
+                <a:solidFill>
+                  <a:srgbClr val="9A9690"/>
+                </a:solidFill>
+                <a:latin typeface="Courier New"/>
               </a:defRPr>
             </a:pPr>
             <a:r>
-              <a:t>THE PENDANT</a:t>
+              <a:t>YOU</a:t>
             </a:r>
           </a:p>
         </p:txBody>
@@ -4828,8 +4634,8 @@
         </p:nvSpPr>
         <p:spPr>
           <a:xfrm>
-            <a:off x="7498079" y="3931920"/>
-            <a:ext cx="3383280" cy="1828800"/>
+            <a:off x="7223760" y="3200400"/>
+            <a:ext cx="3657600" cy="365760"/>
           </a:xfrm>
           <a:prstGeom prst="rect">
             <a:avLst/>
@@ -4844,7 +4650,7 @@
           <a:p>
             <a:pPr algn="l">
               <a:lnSpc>
-                <a:spcPct val="145000"/>
+                <a:spcPct val="120000"/>
               </a:lnSpc>
               <a:spcBef>
                 <a:spcPts val="0"/>
@@ -4852,33 +4658,379 @@
               <a:spcAft>
                 <a:spcPts val="0"/>
               </a:spcAft>
-              <a:defRPr sz="1600" b="0">
-                <a:solidFill>
-                  <a:srgbClr val="6B6860"/>
+              <a:defRPr sz="1400" b="0">
+                <a:solidFill>
+                  <a:srgbClr val="2C2A26"/>
                 </a:solidFill>
                 <a:latin typeface="Calibri"/>
               </a:defRPr>
             </a:pPr>
             <a:r>
-              <a:t>Wearable voice capture device.</a:t>
+              <a:t>Parachute Daily  ·  Pendant  ·  Phone</a:t>
+            </a:r>
+          </a:p>
+        </p:txBody>
+      </p:sp>
+      <p:sp>
+        <p:nvSpPr>
+          <p:cNvPr id="11" name="TextBox 10"/>
+          <p:cNvSpPr txBox="1"/>
+          <p:nvPr/>
+        </p:nvSpPr>
+        <p:spPr>
+          <a:xfrm>
+            <a:off x="8686800" y="3611880"/>
+            <a:ext cx="914400" cy="274320"/>
+          </a:xfrm>
+          <a:prstGeom prst="rect">
+            <a:avLst/>
+          </a:prstGeom>
+          <a:noFill/>
+        </p:spPr>
+        <p:txBody>
+          <a:bodyPr wrap="square">
+            <a:spAutoFit/>
+          </a:bodyPr>
+          <a:lstStyle/>
+          <a:p>
+            <a:pPr algn="ctr">
+              <a:lnSpc>
+                <a:spcPct val="120000"/>
+              </a:lnSpc>
+              <a:spcBef>
+                <a:spcPts val="0"/>
+              </a:spcBef>
+              <a:spcAft>
+                <a:spcPts val="0"/>
+              </a:spcAft>
+              <a:defRPr sz="1400" b="0">
+                <a:solidFill>
+                  <a:srgbClr val="9A9690"/>
+                </a:solidFill>
+                <a:latin typeface="Courier New"/>
+              </a:defRPr>
+            </a:pPr>
+            <a:r>
+              <a:t>↓</a:t>
+            </a:r>
+          </a:p>
+        </p:txBody>
+      </p:sp>
+      <p:sp>
+        <p:nvSpPr>
+          <p:cNvPr id="12" name="TextBox 11"/>
+          <p:cNvSpPr txBox="1"/>
+          <p:nvPr/>
+        </p:nvSpPr>
+        <p:spPr>
+          <a:xfrm>
+            <a:off x="7223760" y="3931920"/>
+            <a:ext cx="3657600" cy="274320"/>
+          </a:xfrm>
+          <a:prstGeom prst="rect">
+            <a:avLst/>
+          </a:prstGeom>
+          <a:noFill/>
+        </p:spPr>
+        <p:txBody>
+          <a:bodyPr wrap="square">
+            <a:spAutoFit/>
+          </a:bodyPr>
+          <a:lstStyle/>
+          <a:p>
+            <a:pPr algn="l">
+              <a:lnSpc>
+                <a:spcPct val="120000"/>
+              </a:lnSpc>
+              <a:spcBef>
+                <a:spcPts val="0"/>
+              </a:spcBef>
+              <a:spcAft>
+                <a:spcPts val="0"/>
+              </a:spcAft>
+              <a:defRPr sz="1000" b="1">
+                <a:solidFill>
+                  <a:srgbClr val="4A7C59"/>
+                </a:solidFill>
+                <a:latin typeface="Courier New"/>
+              </a:defRPr>
+            </a:pPr>
+            <a:r>
+              <a:t>DATA</a:t>
+            </a:r>
+          </a:p>
+        </p:txBody>
+      </p:sp>
+      <p:sp>
+        <p:nvSpPr>
+          <p:cNvPr id="13" name="Rounded Rectangle 12"/>
+          <p:cNvSpPr/>
+          <p:nvPr/>
+        </p:nvSpPr>
+        <p:spPr>
+          <a:xfrm>
+            <a:off x="7132320" y="4160520"/>
+            <a:ext cx="4023360" cy="502920"/>
+          </a:xfrm>
+          <a:prstGeom prst="roundRect">
+            <a:avLst/>
+          </a:prstGeom>
+          <a:solidFill>
+            <a:srgbClr val="E8F5EC"/>
+          </a:solidFill>
+          <a:ln w="12700">
+            <a:solidFill>
+              <a:srgbClr val="4A7C59"/>
+            </a:solidFill>
+          </a:ln>
+        </p:spPr>
+        <p:style>
+          <a:lnRef idx="1">
+            <a:schemeClr val="accent1"/>
+          </a:lnRef>
+          <a:fillRef idx="3">
+            <a:schemeClr val="accent1"/>
+          </a:fillRef>
+          <a:effectRef idx="2">
+            <a:schemeClr val="accent1"/>
+          </a:effectRef>
+          <a:fontRef idx="minor">
+            <a:schemeClr val="lt1"/>
+          </a:fontRef>
+        </p:style>
+        <p:txBody>
+          <a:bodyPr rtlCol="0" anchor="ctr"/>
+          <a:lstStyle/>
+          <a:p>
+            <a:pPr algn="ctr"/>
+          </a:p>
+        </p:txBody>
+      </p:sp>
+      <p:sp>
+        <p:nvSpPr>
+          <p:cNvPr id="14" name="TextBox 13"/>
+          <p:cNvSpPr txBox="1"/>
+          <p:nvPr/>
+        </p:nvSpPr>
+        <p:spPr>
+          <a:xfrm>
+            <a:off x="7315200" y="4206240"/>
+            <a:ext cx="3657600" cy="365760"/>
+          </a:xfrm>
+          <a:prstGeom prst="rect">
+            <a:avLst/>
+          </a:prstGeom>
+          <a:noFill/>
+        </p:spPr>
+        <p:txBody>
+          <a:bodyPr wrap="square">
+            <a:spAutoFit/>
+          </a:bodyPr>
+          <a:lstStyle/>
+          <a:p>
+            <a:pPr algn="l">
+              <a:lnSpc>
+                <a:spcPct val="120000"/>
+              </a:lnSpc>
+              <a:spcBef>
+                <a:spcPts val="0"/>
+              </a:spcBef>
+              <a:spcAft>
+                <a:spcPts val="0"/>
+              </a:spcAft>
+              <a:defRPr sz="1300" b="1">
+                <a:solidFill>
+                  <a:srgbClr val="4A7C59"/>
+                </a:solidFill>
+                <a:latin typeface="Calibri"/>
+              </a:defRPr>
+            </a:pPr>
+            <a:r>
+              <a:t>Parachute Server — Things · Tags · Tools</a:t>
+            </a:r>
+          </a:p>
+        </p:txBody>
+      </p:sp>
+      <p:sp>
+        <p:nvSpPr>
+          <p:cNvPr id="15" name="TextBox 14"/>
+          <p:cNvSpPr txBox="1"/>
+          <p:nvPr/>
+        </p:nvSpPr>
+        <p:spPr>
+          <a:xfrm>
+            <a:off x="8412480" y="4709160"/>
+            <a:ext cx="1371600" cy="274320"/>
+          </a:xfrm>
+          <a:prstGeom prst="rect">
+            <a:avLst/>
+          </a:prstGeom>
+          <a:noFill/>
+        </p:spPr>
+        <p:txBody>
+          <a:bodyPr wrap="square">
+            <a:spAutoFit/>
+          </a:bodyPr>
+          <a:lstStyle/>
+          <a:p>
+            <a:pPr algn="ctr">
+              <a:lnSpc>
+                <a:spcPct val="120000"/>
+              </a:lnSpc>
+              <a:spcBef>
+                <a:spcPts val="0"/>
+              </a:spcBef>
+              <a:spcAft>
+                <a:spcPts val="0"/>
+              </a:spcAft>
+              <a:defRPr sz="1000" b="0">
+                <a:solidFill>
+                  <a:srgbClr val="9A9690"/>
+                </a:solidFill>
+                <a:latin typeface="Courier New"/>
+              </a:defRPr>
+            </a:pPr>
+            <a:r>
+              <a:t>↓ MCP</a:t>
+            </a:r>
+          </a:p>
+        </p:txBody>
+      </p:sp>
+      <p:sp>
+        <p:nvSpPr>
+          <p:cNvPr id="16" name="TextBox 15"/>
+          <p:cNvSpPr txBox="1"/>
+          <p:nvPr/>
+        </p:nvSpPr>
+        <p:spPr>
+          <a:xfrm>
+            <a:off x="7223760" y="5029200"/>
+            <a:ext cx="3657600" cy="274320"/>
+          </a:xfrm>
+          <a:prstGeom prst="rect">
+            <a:avLst/>
+          </a:prstGeom>
+          <a:noFill/>
+        </p:spPr>
+        <p:txBody>
+          <a:bodyPr wrap="square">
+            <a:spAutoFit/>
+          </a:bodyPr>
+          <a:lstStyle/>
+          <a:p>
+            <a:pPr algn="l">
+              <a:lnSpc>
+                <a:spcPct val="120000"/>
+              </a:lnSpc>
+              <a:spcBef>
+                <a:spcPts val="0"/>
+              </a:spcBef>
+              <a:spcAft>
+                <a:spcPts val="0"/>
+              </a:spcAft>
+              <a:defRPr sz="1000" b="1">
+                <a:solidFill>
+                  <a:srgbClr val="9A9690"/>
+                </a:solidFill>
+                <a:latin typeface="Courier New"/>
+              </a:defRPr>
+            </a:pPr>
+            <a:r>
+              <a:t>AGENTS</a:t>
+            </a:r>
+          </a:p>
+        </p:txBody>
+      </p:sp>
+      <p:sp>
+        <p:nvSpPr>
+          <p:cNvPr id="17" name="TextBox 16"/>
+          <p:cNvSpPr txBox="1"/>
+          <p:nvPr/>
+        </p:nvSpPr>
+        <p:spPr>
+          <a:xfrm>
+            <a:off x="7223760" y="5303520"/>
+            <a:ext cx="3657600" cy="365760"/>
+          </a:xfrm>
+          <a:prstGeom prst="rect">
+            <a:avLst/>
+          </a:prstGeom>
+          <a:noFill/>
+        </p:spPr>
+        <p:txBody>
+          <a:bodyPr wrap="square">
+            <a:spAutoFit/>
+          </a:bodyPr>
+          <a:lstStyle/>
+          <a:p>
+            <a:pPr algn="l">
+              <a:lnSpc>
+                <a:spcPct val="120000"/>
+              </a:lnSpc>
+              <a:spcBef>
+                <a:spcPts val="0"/>
+              </a:spcBef>
+              <a:spcAft>
+                <a:spcPts val="0"/>
+              </a:spcAft>
+              <a:defRPr sz="1400" b="0">
+                <a:solidFill>
+                  <a:srgbClr val="2C2A26"/>
+                </a:solidFill>
+                <a:latin typeface="Calibri"/>
+              </a:defRPr>
+            </a:pPr>
+            <a:r>
+              <a:t>Claude  ·  ChatGPT  ·  OpenClaw  ·  Any AI</a:t>
+            </a:r>
+          </a:p>
+        </p:txBody>
+      </p:sp>
+      <p:sp>
+        <p:nvSpPr>
+          <p:cNvPr id="18" name="TextBox 17"/>
+          <p:cNvSpPr txBox="1"/>
+          <p:nvPr/>
+        </p:nvSpPr>
+        <p:spPr>
+          <a:xfrm>
+            <a:off x="1097280" y="5760720"/>
+            <a:ext cx="9144000" cy="548640"/>
+          </a:xfrm>
+          <a:prstGeom prst="rect">
+            <a:avLst/>
+          </a:prstGeom>
+          <a:noFill/>
+        </p:spPr>
+        <p:txBody>
+          <a:bodyPr wrap="square">
+            <a:spAutoFit/>
+          </a:bodyPr>
+          <a:lstStyle/>
+          <a:p>
+            <a:pPr algn="l">
+              <a:lnSpc>
+                <a:spcPct val="130000"/>
+              </a:lnSpc>
+              <a:spcBef>
+                <a:spcPts val="0"/>
+              </a:spcBef>
+              <a:spcAft>
+                <a:spcPts val="0"/>
+              </a:spcAft>
+              <a:defRPr sz="2000" b="0">
+                <a:solidFill>
+                  <a:srgbClr val="2C2A26"/>
+                </a:solidFill>
+                <a:latin typeface="Georgia"/>
+              </a:defRPr>
+            </a:pPr>
+            <a:r>
+              <a:t>We’re not trying to build the most intelligent tool.</a:t>
             </a:r>
             <a:br/>
-            <a:br/>
-            <a:r>
-              <a:t>Go for a walk. Talk.</a:t>
-            </a:r>
-            <a:br/>
-            <a:r>
-              <a:t>Your thoughts become structured</a:t>
-            </a:r>
-            <a:br/>
-            <a:r>
-              <a:t>knowledge by the time you’re home.</a:t>
-            </a:r>
-            <a:br/>
-            <a:br/>
-            <a:r>
-              <a:t>Working prototype on stage today.</a:t>
+            <a:r>
+              <a:t>We’re building the most important tool for intelligent systems to use.</a:t>
             </a:r>
           </a:p>
         </p:txBody>
@@ -5118,11 +5270,11 @@
               </a:defRPr>
             </a:pPr>
             <a:r>
-              <a:t>Every day you use Parachute, your AI gets meaningfully better.</a:t>
+              <a:t>Every note, every voice entry builds a richer personal data layer —</a:t>
             </a:r>
             <a:br/>
             <a:r>
-              <a:t>No competitor can shortcut months of accumulated personal context.</a:t>
+              <a:t>not a flat text file, but a real graph that can be queried across months and years.</a:t>
             </a:r>
           </a:p>
         </p:txBody>
@@ -5212,7 +5364,7 @@
               </a:defRPr>
             </a:pPr>
             <a:r>
-              <a:t>Start journaling in Daily</a:t>
+              <a:t>Capture thoughts in Daily</a:t>
             </a:r>
           </a:p>
         </p:txBody>
@@ -5392,7 +5544,7 @@
               </a:defRPr>
             </a:pPr>
             <a:r>
-              <a:t>Upgrade to Parachute Computer</a:t>
+              <a:t>Connect any AI via MCP</a:t>
             </a:r>
           </a:p>
         </p:txBody>
@@ -5482,7 +5634,7 @@
               </a:defRPr>
             </a:pPr>
             <a:r>
-              <a:t>Brain ingests your history instantly</a:t>
+              <a:t>AI already knows you</a:t>
             </a:r>
           </a:p>
         </p:txBody>
@@ -5572,7 +5724,69 @@
               </a:defRPr>
             </a:pPr>
             <a:r>
-              <a:t>System already knows you</a:t>
+              <a:t>Switching cost through genuine value</a:t>
+            </a:r>
+          </a:p>
+        </p:txBody>
+      </p:sp>
+      <p:sp>
+        <p:nvSpPr>
+          <p:cNvPr id="17" name="TextBox 16"/>
+          <p:cNvSpPr txBox="1"/>
+          <p:nvPr/>
+        </p:nvSpPr>
+        <p:spPr>
+          <a:xfrm>
+            <a:off x="6858000" y="4206240"/>
+            <a:ext cx="4572000" cy="1828800"/>
+          </a:xfrm>
+          <a:prstGeom prst="rect">
+            <a:avLst/>
+          </a:prstGeom>
+          <a:noFill/>
+        </p:spPr>
+        <p:txBody>
+          <a:bodyPr wrap="square">
+            <a:spAutoFit/>
+          </a:bodyPr>
+          <a:lstStyle/>
+          <a:p>
+            <a:pPr algn="l">
+              <a:lnSpc>
+                <a:spcPct val="150000"/>
+              </a:lnSpc>
+              <a:spcBef>
+                <a:spcPts val="0"/>
+              </a:spcBef>
+              <a:spcAft>
+                <a:spcPts val="0"/>
+              </a:spcAft>
+              <a:defRPr sz="1600" b="0">
+                <a:solidFill>
+                  <a:srgbClr val="6B6860"/>
+                </a:solidFill>
+                <a:latin typeface="Calibri"/>
+              </a:defRPr>
+            </a:pPr>
+            <a:r>
+              <a:t>Open source (AGPL-3.0)</a:t>
+            </a:r>
+            <a:br/>
+            <a:r>
+              <a:t>Local-first</a:t>
+            </a:r>
+            <a:br/>
+            <a:r>
+              <a:t>Public Benefit Corporation</a:t>
+            </a:r>
+            <a:br/>
+            <a:br/>
+            <a:r>
+              <a:t>Your data is yours —</a:t>
+            </a:r>
+            <a:br/>
+            <a:r>
+              <a:t>portable, exportable, self-hostable.</a:t>
             </a:r>
           </a:p>
         </p:txBody>
@@ -5874,7 +6088,7 @@
         </p:nvSpPr>
         <p:spPr>
           <a:xfrm>
-            <a:off x="1097280" y="3657600"/>
+            <a:off x="1097280" y="3749040"/>
             <a:ext cx="1645920" cy="365760"/>
           </a:xfrm>
           <a:prstGeom prst="rect">
@@ -5919,7 +6133,7 @@
         </p:nvSpPr>
         <p:spPr>
           <a:xfrm>
-            <a:off x="2926080" y="3685032"/>
+            <a:off x="2926080" y="3776472"/>
             <a:ext cx="7315200" cy="365760"/>
           </a:xfrm>
           <a:prstGeom prst="rect">
@@ -5951,7 +6165,7 @@
               </a:defRPr>
             </a:pPr>
             <a:r>
-              <a:t>Cloud sync across devices. Your notes everywhere.</a:t>
+              <a:t>Cloud sync + MCP access — your notes available to any AI</a:t>
             </a:r>
           </a:p>
         </p:txBody>
@@ -5964,7 +6178,7 @@
         </p:nvSpPr>
         <p:spPr>
           <a:xfrm>
-            <a:off x="1097280" y="4206240"/>
+            <a:off x="1097280" y="4389120"/>
             <a:ext cx="1645920" cy="365760"/>
           </a:xfrm>
           <a:prstGeom prst="rect">
@@ -6009,7 +6223,7 @@
         </p:nvSpPr>
         <p:spPr>
           <a:xfrm>
-            <a:off x="2926080" y="4233672"/>
+            <a:off x="2926080" y="4416552"/>
             <a:ext cx="7315200" cy="365760"/>
           </a:xfrm>
           <a:prstGeom prst="rect">
@@ -6054,7 +6268,7 @@
         </p:nvSpPr>
         <p:spPr>
           <a:xfrm>
-            <a:off x="914400" y="4663440"/>
+            <a:off x="914400" y="4937760"/>
             <a:ext cx="9601200" cy="502920"/>
           </a:xfrm>
           <a:prstGeom prst="roundRect">
@@ -6097,7 +6311,7 @@
         </p:nvSpPr>
         <p:spPr>
           <a:xfrm>
-            <a:off x="1097280" y="4754880"/>
+            <a:off x="1097280" y="5029200"/>
             <a:ext cx="1645920" cy="365760"/>
           </a:xfrm>
           <a:prstGeom prst="rect">
@@ -6142,7 +6356,7 @@
         </p:nvSpPr>
         <p:spPr>
           <a:xfrm>
-            <a:off x="2926080" y="4782312"/>
+            <a:off x="2926080" y="5056632"/>
             <a:ext cx="7315200" cy="365760"/>
           </a:xfrm>
           <a:prstGeom prst="rect">
@@ -6174,7 +6388,7 @@
               </a:defRPr>
             </a:pPr>
             <a:r>
-              <a:t>AI reflections, synthesis, and pattern surfacing</a:t>
+              <a:t>AI reflections, vector search, and synthesis</a:t>
             </a:r>
           </a:p>
         </p:txBody>
@@ -6182,96 +6396,6 @@
       <p:sp>
         <p:nvSpPr>
           <p:cNvPr id="15" name="TextBox 14"/>
-          <p:cNvSpPr txBox="1"/>
-          <p:nvPr/>
-        </p:nvSpPr>
-        <p:spPr>
-          <a:xfrm>
-            <a:off x="1097280" y="5303520"/>
-            <a:ext cx="1645920" cy="365760"/>
-          </a:xfrm>
-          <a:prstGeom prst="rect">
-            <a:avLst/>
-          </a:prstGeom>
-          <a:noFill/>
-        </p:spPr>
-        <p:txBody>
-          <a:bodyPr wrap="square">
-            <a:spAutoFit/>
-          </a:bodyPr>
-          <a:lstStyle/>
-          <a:p>
-            <a:pPr algn="l">
-              <a:lnSpc>
-                <a:spcPct val="120000"/>
-              </a:lnSpc>
-              <a:spcBef>
-                <a:spcPts val="0"/>
-              </a:spcBef>
-              <a:spcAft>
-                <a:spcPts val="0"/>
-              </a:spcAft>
-              <a:defRPr sz="2200" b="0">
-                <a:solidFill>
-                  <a:srgbClr val="2C2A26"/>
-                </a:solidFill>
-                <a:latin typeface="Georgia"/>
-              </a:defRPr>
-            </a:pPr>
-            <a:r>
-              <a:t>$40/mo</a:t>
-            </a:r>
-          </a:p>
-        </p:txBody>
-      </p:sp>
-      <p:sp>
-        <p:nvSpPr>
-          <p:cNvPr id="16" name="TextBox 15"/>
-          <p:cNvSpPr txBox="1"/>
-          <p:nvPr/>
-        </p:nvSpPr>
-        <p:spPr>
-          <a:xfrm>
-            <a:off x="2926080" y="5330952"/>
-            <a:ext cx="7315200" cy="365760"/>
-          </a:xfrm>
-          <a:prstGeom prst="rect">
-            <a:avLst/>
-          </a:prstGeom>
-          <a:noFill/>
-        </p:spPr>
-        <p:txBody>
-          <a:bodyPr wrap="square">
-            <a:spAutoFit/>
-          </a:bodyPr>
-          <a:lstStyle/>
-          <a:p>
-            <a:pPr algn="l">
-              <a:lnSpc>
-                <a:spcPct val="120000"/>
-              </a:lnSpc>
-              <a:spcBef>
-                <a:spcPts val="0"/>
-              </a:spcBef>
-              <a:spcAft>
-                <a:spcPts val="0"/>
-              </a:spcAft>
-              <a:defRPr sz="1500" b="0">
-                <a:solidFill>
-                  <a:srgbClr val="6B6860"/>
-                </a:solidFill>
-                <a:latin typeface="Calibri"/>
-              </a:defRPr>
-            </a:pPr>
-            <a:r>
-              <a:t>Hosted Parachute Computer — full agentic platform with bundled AI</a:t>
-            </a:r>
-          </a:p>
-        </p:txBody>
-      </p:sp>
-      <p:sp>
-        <p:nvSpPr>
-          <p:cNvPr id="17" name="TextBox 16"/>
           <p:cNvSpPr txBox="1"/>
           <p:nvPr/>
         </p:nvSpPr>
@@ -6301,7 +6425,7 @@
               <a:spcAft>
                 <a:spcPts val="0"/>
               </a:spcAft>
-              <a:defRPr sz="1400" b="0">
+              <a:defRPr sz="1500" b="0">
                 <a:solidFill>
                   <a:srgbClr val="9A9690"/>
                 </a:solidFill>
@@ -6309,11 +6433,11 @@
               </a:defRPr>
             </a:pPr>
             <a:r>
-              <a:t>Free tier has zero hosting cost. AI at $10/mo uses cost-efficient models.</a:t>
+              <a:t>We’re not competing with anyone’s AI subscription.</a:t>
             </a:r>
             <a:br/>
             <a:r>
-              <a:t>Margins are real and improve as model costs drop.</a:t>
+              <a:t>$2/mo to make whatever AI you’re already paying for dramatically better.</a:t>
             </a:r>
           </a:p>
         </p:txBody>
@@ -6727,7 +6851,7 @@
                         </a:defRPr>
                       </a:pPr>
                       <a:r>
-                        <a:t>Free + sync users</a:t>
+                        <a:t>Free users</a:t>
                       </a:r>
                     </a:p>
                   </a:txBody>
@@ -6815,7 +6939,7 @@
                         </a:defRPr>
                       </a:pPr>
                       <a:r>
-                        <a:t>50,000</a:t>
+                        <a:t>75,000</a:t>
                       </a:r>
                     </a:p>
                   </a:txBody>
@@ -6859,7 +6983,7 @@
                         </a:defRPr>
                       </a:pPr>
                       <a:r>
-                        <a:t>250,000</a:t>
+                        <a:t>500,000</a:t>
                       </a:r>
                     </a:p>
                   </a:txBody>
@@ -6993,7 +7117,7 @@
                         </a:defRPr>
                       </a:pPr>
                       <a:r>
-                        <a:t>5,000</a:t>
+                        <a:t>8,000</a:t>
                       </a:r>
                     </a:p>
                   </a:txBody>
@@ -7037,7 +7161,7 @@
                         </a:defRPr>
                       </a:pPr>
                       <a:r>
-                        <a:t>25,000</a:t>
+                        <a:t>50,000</a:t>
                       </a:r>
                     </a:p>
                   </a:txBody>
@@ -7127,7 +7251,7 @@
                         </a:defRPr>
                       </a:pPr>
                       <a:r>
-                        <a:t>~$7/mo</a:t>
+                        <a:t>~$5/mo</a:t>
                       </a:r>
                     </a:p>
                   </a:txBody>
@@ -7171,7 +7295,7 @@
                         </a:defRPr>
                       </a:pPr>
                       <a:r>
-                        <a:t>~$9/mo</a:t>
+                        <a:t>~$5/mo</a:t>
                       </a:r>
                     </a:p>
                   </a:txBody>
@@ -7215,7 +7339,7 @@
                         </a:defRPr>
                       </a:pPr>
                       <a:r>
-                        <a:t>~$12/mo</a:t>
+                        <a:t>~$5/mo</a:t>
                       </a:r>
                     </a:p>
                   </a:txBody>
@@ -7305,7 +7429,7 @@
                         </a:defRPr>
                       </a:pPr>
                       <a:r>
-                        <a:t>~$42K</a:t>
+                        <a:t>~$30K</a:t>
                       </a:r>
                     </a:p>
                   </a:txBody>
@@ -7349,7 +7473,7 @@
                         </a:defRPr>
                       </a:pPr>
                       <a:r>
-                        <a:t>~$540K</a:t>
+                        <a:t>~$480K</a:t>
                       </a:r>
                     </a:p>
                   </a:txBody>
@@ -7393,7 +7517,7 @@
                         </a:defRPr>
                       </a:pPr>
                       <a:r>
-                        <a:t>~$3.6M</a:t>
+                        <a:t>~$3M</a:t>
                       </a:r>
                     </a:p>
                   </a:txBody>
@@ -7661,7 +7785,7 @@
                         </a:defRPr>
                       </a:pPr>
                       <a:r>
-                        <a:t>~$15K</a:t>
+                        <a:t>~$10K</a:t>
                       </a:r>
                     </a:p>
                   </a:txBody>
@@ -7705,7 +7829,7 @@
                         </a:defRPr>
                       </a:pPr>
                       <a:r>
-                        <a:t>~$130K</a:t>
+                        <a:t>~$100K</a:t>
                       </a:r>
                     </a:p>
                   </a:txBody>
@@ -7749,7 +7873,7 @@
                         </a:defRPr>
                       </a:pPr>
                       <a:r>
-                        <a:t>~$500K</a:t>
+                        <a:t>~$400K</a:t>
                       </a:r>
                     </a:p>
                   </a:txBody>
@@ -7839,7 +7963,7 @@
                         </a:defRPr>
                       </a:pPr>
                       <a:r>
-                        <a:t>~$165K</a:t>
+                        <a:t>~$160K</a:t>
                       </a:r>
                     </a:p>
                   </a:txBody>
@@ -7883,7 +8007,7 @@
                         </a:defRPr>
                       </a:pPr>
                       <a:r>
-                        <a:t>~$530K</a:t>
+                        <a:t>~$500K</a:t>
                       </a:r>
                     </a:p>
                   </a:txBody>
@@ -7927,7 +8051,7 @@
                         </a:defRPr>
                       </a:pPr>
                       <a:r>
-                        <a:t>~$1.3M</a:t>
+                        <a:t>~$1.2M</a:t>
                       </a:r>
                     </a:p>
                   </a:txBody>
@@ -8002,7 +8126,7 @@
               </a:defRPr>
             </a:pPr>
             <a:r>
-              <a:t>Year two approaches breakeven. Year three clearly profitable as tier mix shifts upward.</a:t>
+              <a:t>100M+ AI users are all potential customers. Conservative given the scale of the opportunity.</a:t>
             </a:r>
           </a:p>
         </p:txBody>
@@ -8291,7 +8415,7 @@
               </a:defRPr>
             </a:pPr>
             <a:r>
-              <a:t>Working app with local voice transcription + graph-native memory</a:t>
+              <a:t>Working app with local voice transcription + graph-native storage</a:t>
             </a:r>
           </a:p>
         </p:txBody>
@@ -8381,7 +8505,7 @@
               </a:defRPr>
             </a:pPr>
             <a:r>
-              <a:t>Multi-platform: phone, Telegram, Discord, Matrix</a:t>
+              <a:t>MCP server with Things, Tags, Tools architecture</a:t>
             </a:r>
           </a:p>
         </p:txBody>
@@ -8921,7 +9045,7 @@
               </a:defRPr>
             </a:pPr>
             <a:r>
-              <a:t>Computer co-lead · Founding engineer</a:t>
+              <a:t>Server co-lead · Founding engineer</a:t>
             </a:r>
           </a:p>
         </p:txBody>
@@ -9341,11 +9465,11 @@
               </a:defRPr>
             </a:pPr>
             <a:r>
-              <a:t>Raising $300K to hire</a:t>
+              <a:t>Raising $300K to launch</a:t>
             </a:r>
             <a:br/>
             <a:r>
-              <a:t>the core team.</a:t>
+              <a:t>the personal data layer.</a:t>
             </a:r>
           </a:p>
         </p:txBody>
@@ -9705,11 +9829,11 @@
               </a:defRPr>
             </a:pPr>
             <a:r>
-              <a:t>Open source. Local-first.</a:t>
+              <a:t>Don’t compete with agents.</a:t>
             </a:r>
             <a:br/>
             <a:r>
-              <a:t>Balance and choice — from the foundation.</a:t>
+              <a:t>Build what they all need.</a:t>
             </a:r>
           </a:p>
         </p:txBody>

</xml_diff>